<commit_message>
System Design vi: scope bearer-token possession and ID token claims in sd-14-035
Co-Authored-By: Claude Sonnet 5.5 <noreply@anthropic.com>
Claude-Session: https://claude.ai/code/session_01WnjciXNJBLEd8jy3HrG49S
</commit_message>
<xml_diff>
--- a/system-design-101/vi/lessons/sd-14-035/slides/sd-14-035.pptx
+++ b/system-design-101/vi/lessons/sd-14-035/slides/sd-14-035.pptx
@@ -3440,7 +3440,7 @@
               <a:t>KHÔNG</a:t>
             </a:r>
             <a:r>
-              <a:rPr lang="en-US" sz="1650" b="1" spc="225" kern="0" dirty="0">
+              <a:rPr lang="en-US" sz="1650" b="1" spc="223" kern="0" dirty="0">
                 <a:solidFill>
                   <a:srgbClr val="FF6A4D"/>
                 </a:solidFill>
@@ -3448,7 +3448,18 @@
                 <a:ea typeface="Be Vietnam Pro" pitchFamily="34" charset="-122"/>
                 <a:cs typeface="Be Vietnam Pro" pitchFamily="34" charset="-120"/>
               </a:rPr>
-              <a:t> LÀM</a:t>
+              <a:t> TRẢ</a:t>
+            </a:r>
+            <a:r>
+              <a:rPr lang="en-US" sz="1650" b="1" spc="209" kern="0" dirty="0">
+                <a:solidFill>
+                  <a:srgbClr val="FF6A4D"/>
+                </a:solidFill>
+                <a:latin typeface="Be Vietnam Pro" pitchFamily="34" charset="0"/>
+                <a:ea typeface="Be Vietnam Pro" pitchFamily="34" charset="-122"/>
+                <a:cs typeface="Be Vietnam Pro" pitchFamily="34" charset="-120"/>
+              </a:rPr>
+              <a:t> LỜI</a:t>
             </a:r>
             <a:r>
               <a:rPr lang="en-US" sz="1650" b="1" spc="229" kern="0" dirty="0">
@@ -3474,7 +3485,7 @@
         <p:spPr>
           <a:xfrm>
             <a:off x="11639550" y="6800850"/>
-            <a:ext cx="5715000" cy="419100"/>
+            <a:ext cx="5753100" cy="419100"/>
           </a:xfrm>
           <a:prstGeom prst="rect">
             <a:avLst/>
@@ -3490,7 +3501,7 @@
               <a:buNone/>
             </a:pPr>
             <a:r>
-              <a:rPr lang="en-US" sz="2400" dirty="0" spc="21" kern="0">
+              <a:rPr lang="en-US" sz="2400" dirty="0" spc="0" kern="0">
                 <a:solidFill>
                   <a:srgbClr val="D8D3C4"/>
                 </a:solidFill>
@@ -3498,7 +3509,62 @@
                 <a:ea typeface="Be Vietnam Pro" pitchFamily="34" charset="-122"/>
                 <a:cs typeface="Be Vietnam Pro" pitchFamily="34" charset="-120"/>
               </a:rPr>
-              <a:t>Chứng</a:t>
+              <a:t>Ai</a:t>
+            </a:r>
+            <a:r>
+              <a:rPr lang="en-US" sz="2400" dirty="0" spc="12" kern="0">
+                <a:solidFill>
+                  <a:srgbClr val="D8D3C4"/>
+                </a:solidFill>
+                <a:latin typeface="Be Vietnam Pro" pitchFamily="34" charset="0"/>
+                <a:ea typeface="Be Vietnam Pro" pitchFamily="34" charset="-122"/>
+                <a:cs typeface="Be Vietnam Pro" pitchFamily="34" charset="-120"/>
+              </a:rPr>
+              <a:t> đăng</a:t>
+            </a:r>
+            <a:r>
+              <a:rPr lang="en-US" sz="2400" dirty="0" spc="2" kern="0">
+                <a:solidFill>
+                  <a:srgbClr val="D8D3C4"/>
+                </a:solidFill>
+                <a:latin typeface="Be Vietnam Pro" pitchFamily="34" charset="0"/>
+                <a:ea typeface="Be Vietnam Pro" pitchFamily="34" charset="-122"/>
+                <a:cs typeface="Be Vietnam Pro" pitchFamily="34" charset="-120"/>
+              </a:rPr>
+              <a:t> nhập,</a:t>
+            </a:r>
+            <a:r>
+              <a:rPr lang="en-US" sz="2400" dirty="0" spc="-15" kern="0">
+                <a:solidFill>
+                  <a:srgbClr val="D8D3C4"/>
+                </a:solidFill>
+                <a:latin typeface="Be Vietnam Pro" pitchFamily="34" charset="0"/>
+                <a:ea typeface="Be Vietnam Pro" pitchFamily="34" charset="-122"/>
+                <a:cs typeface="Be Vietnam Pro" pitchFamily="34" charset="-120"/>
+              </a:rPr>
+              <a:t> và</a:t>
+            </a:r>
+            <a:r>
+              <a:rPr lang="en-US" sz="2400" dirty="0" spc="10" kern="0">
+                <a:solidFill>
+                  <a:srgbClr val="D8D3C4"/>
+                </a:solidFill>
+                <a:latin typeface="Be Vietnam Pro" pitchFamily="34" charset="0"/>
+                <a:ea typeface="Be Vietnam Pro" pitchFamily="34" charset="-122"/>
+                <a:cs typeface="Be Vietnam Pro" pitchFamily="34" charset="-120"/>
+              </a:rPr>
+              <a:t> vừa</a:t>
+            </a:r>
+            <a:r>
+              <a:rPr lang="en-US" sz="2400" dirty="0" spc="13" kern="0">
+                <a:solidFill>
+                  <a:srgbClr val="D8D3C4"/>
+                </a:solidFill>
+                <a:latin typeface="Be Vietnam Pro" pitchFamily="34" charset="0"/>
+                <a:ea typeface="Be Vietnam Pro" pitchFamily="34" charset="-122"/>
+                <a:cs typeface="Be Vietnam Pro" pitchFamily="34" charset="-120"/>
+              </a:rPr>
+              <a:t> đăng</a:t>
             </a:r>
             <a:r>
               <a:rPr lang="en-US" sz="2400" dirty="0" spc="1" kern="0">
@@ -3509,10 +3575,10 @@
                 <a:ea typeface="Be Vietnam Pro" pitchFamily="34" charset="-122"/>
                 <a:cs typeface="Be Vietnam Pro" pitchFamily="34" charset="-120"/>
               </a:rPr>
-              <a:t> minh</a:t>
-            </a:r>
-            <a:r>
-              <a:rPr lang="en-US" sz="2400" dirty="0" spc="-1" kern="0">
+              <a:t> nhập</a:t>
+            </a:r>
+            <a:r>
+              <a:rPr lang="en-US" sz="2400" dirty="0" spc="7" kern="0">
                 <a:solidFill>
                   <a:srgbClr val="D8D3C4"/>
                 </a:solidFill>
@@ -3520,40 +3586,7 @@
                 <a:ea typeface="Be Vietnam Pro" pitchFamily="34" charset="-122"/>
                 <a:cs typeface="Be Vietnam Pro" pitchFamily="34" charset="-120"/>
               </a:rPr>
-              <a:t> bạn</a:t>
-            </a:r>
-            <a:r>
-              <a:rPr lang="en-US" sz="2400" dirty="0" spc="10" kern="0">
-                <a:solidFill>
-                  <a:srgbClr val="D8D3C4"/>
-                </a:solidFill>
-                <a:latin typeface="Be Vietnam Pro" pitchFamily="34" charset="0"/>
-                <a:ea typeface="Be Vietnam Pro" pitchFamily="34" charset="-122"/>
-                <a:cs typeface="Be Vietnam Pro" pitchFamily="34" charset="-120"/>
-              </a:rPr>
-              <a:t> vừa</a:t>
-            </a:r>
-            <a:r>
-              <a:rPr lang="en-US" sz="2400" dirty="0" spc="13" kern="0">
-                <a:solidFill>
-                  <a:srgbClr val="D8D3C4"/>
-                </a:solidFill>
-                <a:latin typeface="Be Vietnam Pro" pitchFamily="34" charset="0"/>
-                <a:ea typeface="Be Vietnam Pro" pitchFamily="34" charset="-122"/>
-                <a:cs typeface="Be Vietnam Pro" pitchFamily="34" charset="-120"/>
-              </a:rPr>
-              <a:t> đăng</a:t>
-            </a:r>
-            <a:r>
-              <a:rPr lang="en-US" sz="2400" dirty="0" spc="1" kern="0">
-                <a:solidFill>
-                  <a:srgbClr val="D8D3C4"/>
-                </a:solidFill>
-                <a:latin typeface="Be Vietnam Pro" pitchFamily="34" charset="0"/>
-                <a:ea typeface="Be Vietnam Pro" pitchFamily="34" charset="-122"/>
-                <a:cs typeface="Be Vietnam Pro" pitchFamily="34" charset="-120"/>
-              </a:rPr>
-              <a:t> nhập</a:t>
+              <a:t> chưa</a:t>
             </a:r>
             <a:endParaRPr lang="en-US" sz="2400" dirty="0"/>
           </a:p>
@@ -16220,7 +16253,40 @@
               <a:t> và</a:t>
             </a:r>
             <a:r>
-              <a:rPr lang="en-US" sz="2700" dirty="0" spc="-2" kern="0">
+              <a:rPr lang="en-US" sz="2700" dirty="0" spc="-14" kern="0">
+                <a:solidFill>
+                  <a:srgbClr val="14161C"/>
+                </a:solidFill>
+                <a:latin typeface="Be Vietnam Pro" pitchFamily="34" charset="0"/>
+                <a:ea typeface="Be Vietnam Pro" pitchFamily="34" charset="-122"/>
+                <a:cs typeface="Be Vietnam Pro" pitchFamily="34" charset="-120"/>
+              </a:rPr>
+              <a:t> với</a:t>
+            </a:r>
+            <a:r>
+              <a:rPr lang="en-US" sz="2700" dirty="0" spc="-29" kern="0">
+                <a:solidFill>
+                  <a:srgbClr val="14161C"/>
+                </a:solidFill>
+                <a:latin typeface="Be Vietnam Pro" pitchFamily="34" charset="0"/>
+                <a:ea typeface="Be Vietnam Pro" pitchFamily="34" charset="-122"/>
+                <a:cs typeface="Be Vietnam Pro" pitchFamily="34" charset="-120"/>
+              </a:rPr>
+              <a:t> token</a:t>
+            </a:r>
+            <a:r>
+              <a:rPr lang="en-US" sz="2700" dirty="0" spc="-18" kern="0">
+                <a:solidFill>
+                  <a:srgbClr val="14161C"/>
+                </a:solidFill>
+                <a:latin typeface="Be Vietnam Pro" pitchFamily="34" charset="0"/>
+                <a:ea typeface="Be Vietnam Pro" pitchFamily="34" charset="-122"/>
+                <a:cs typeface="Be Vietnam Pro" pitchFamily="34" charset="-120"/>
+              </a:rPr>
+              <a:t> bearer,</a:t>
+            </a:r>
+            <a:r>
+              <a:rPr lang="en-US" sz="2700" dirty="0" spc="-1" kern="0">
                 <a:solidFill>
                   <a:srgbClr val="14161C"/>
                 </a:solidFill>
@@ -16298,11 +16364,11 @@
         <p:spPr>
           <a:xfrm>
             <a:off x="914400" y="3810000"/>
-            <a:ext cx="5257800" cy="4762500"/>
+            <a:ext cx="5257800" cy="4953000"/>
           </a:xfrm>
           <a:prstGeom prst="roundRect">
             <a:avLst>
-              <a:gd name="adj" fmla="val 5600"/>
+              <a:gd name="adj" fmla="val 5385"/>
             </a:avLst>
           </a:prstGeom>
           <a:solidFill>
@@ -16473,7 +16539,7 @@
         <p:spPr>
           <a:xfrm>
             <a:off x="1295400" y="6572250"/>
-            <a:ext cx="4572000" cy="1143000"/>
+            <a:ext cx="4572000" cy="1190625"/>
           </a:xfrm>
           <a:prstGeom prst="rect">
             <a:avLst/>
@@ -16492,6 +16558,39 @@
               <a:buNone/>
             </a:pPr>
             <a:r>
+              <a:rPr lang="en-US" sz="2250" dirty="0" spc="3" kern="0">
+                <a:solidFill>
+                  <a:srgbClr val="14161C"/>
+                </a:solidFill>
+                <a:latin typeface="Be Vietnam Pro" pitchFamily="34" charset="0"/>
+                <a:ea typeface="Be Vietnam Pro" pitchFamily="34" charset="-122"/>
+                <a:cs typeface="Be Vietnam Pro" pitchFamily="34" charset="-120"/>
+              </a:rPr>
+              <a:t>ID</a:t>
+            </a:r>
+            <a:r>
+              <a:rPr lang="en-US" sz="2250" dirty="0" spc="-25" kern="0">
+                <a:solidFill>
+                  <a:srgbClr val="14161C"/>
+                </a:solidFill>
+                <a:latin typeface="Be Vietnam Pro" pitchFamily="34" charset="0"/>
+                <a:ea typeface="Be Vietnam Pro" pitchFamily="34" charset="-122"/>
+                <a:cs typeface="Be Vietnam Pro" pitchFamily="34" charset="-120"/>
+              </a:rPr>
+              <a:t> token</a:t>
+            </a:r>
+            <a:r>
+              <a:rPr lang="en-US" sz="2250" dirty="0" spc="1" kern="0">
+                <a:solidFill>
+                  <a:srgbClr val="14161C"/>
+                </a:solidFill>
+                <a:latin typeface="Be Vietnam Pro" pitchFamily="34" charset="0"/>
+                <a:ea typeface="Be Vietnam Pro" pitchFamily="34" charset="-122"/>
+                <a:cs typeface="Be Vietnam Pro" pitchFamily="34" charset="-120"/>
+              </a:rPr>
+              <a:t> cho</a:t>
+            </a:r>
+            <a:r>
               <a:rPr lang="en-US" sz="2250" dirty="0" spc="-4" kern="0">
                 <a:solidFill>
                   <a:srgbClr val="14161C"/>
@@ -16500,7 +16599,7 @@
                 <a:ea typeface="Be Vietnam Pro" pitchFamily="34" charset="-122"/>
                 <a:cs typeface="Be Vietnam Pro" pitchFamily="34" charset="-120"/>
               </a:rPr>
-              <a:t>Việc</a:t>
+              <a:t> biết ai;</a:t>
             </a:r>
             <a:r>
               <a:rPr lang="en-US" sz="2250" dirty="0" spc="19" kern="0">
@@ -16511,7 +16610,51 @@
                 <a:ea typeface="Be Vietnam Pro" pitchFamily="34" charset="-122"/>
                 <a:cs typeface="Be Vietnam Pro" pitchFamily="34" charset="-120"/>
               </a:rPr>
-              <a:t> đó</a:t>
+              <a:t> độ</a:t>
+            </a:r>
+            <a:r>
+              <a:rPr lang="en-US" sz="2250" dirty="0" spc="0" kern="0">
+                <a:solidFill>
+                  <a:srgbClr val="14161C"/>
+                </a:solidFill>
+                <a:latin typeface="Be Vietnam Pro" pitchFamily="34" charset="0"/>
+                <a:ea typeface="Be Vietnam Pro" pitchFamily="34" charset="-122"/>
+                <a:cs typeface="Be Vietnam Pro" pitchFamily="34" charset="-120"/>
+              </a:rPr>
+              <a:t> mới</a:t>
+            </a:r>
+            <a:r>
+              <a:rPr lang="en-US" sz="2250" dirty="0" spc="2" kern="0">
+                <a:solidFill>
+                  <a:srgbClr val="14161C"/>
+                </a:solidFill>
+                <a:latin typeface="Be Vietnam Pro" pitchFamily="34" charset="0"/>
+                <a:ea typeface="Be Vietnam Pro" pitchFamily="34" charset="-122"/>
+                <a:cs typeface="Be Vietnam Pro" pitchFamily="34" charset="-120"/>
+              </a:rPr>
+              <a:t> của</a:t>
+            </a:r>
+            <a:r>
+              <a:rPr lang="en-US" sz="2250" dirty="0" spc="0" kern="0">
+                <a:solidFill>
+                  <a:srgbClr val="14161C"/>
+                </a:solidFill>
+                <a:latin typeface="Be Vietnam Pro" pitchFamily="34" charset="0"/>
+                <a:ea typeface="Be Vietnam Pro" pitchFamily="34" charset="-122"/>
+                <a:cs typeface="Be Vietnam Pro" pitchFamily="34" charset="-120"/>
+              </a:rPr>
+              <a:t> lần</a:t>
+            </a:r>
+            <a:r>
+              <a:rPr lang="en-US" sz="2250" dirty="0" spc="9" kern="0">
+                <a:solidFill>
+                  <a:srgbClr val="14161C"/>
+                </a:solidFill>
+                <a:latin typeface="Be Vietnam Pro" pitchFamily="34" charset="0"/>
+                <a:ea typeface="Be Vietnam Pro" pitchFamily="34" charset="-122"/>
+                <a:cs typeface="Be Vietnam Pro" pitchFamily="34" charset="-120"/>
+              </a:rPr>
+              <a:t> đăng</a:t>
             </a:r>
             <a:r>
               <a:rPr lang="en-US" sz="2250" dirty="0" spc="1" kern="0">
@@ -16522,40 +16665,73 @@
                 <a:ea typeface="Be Vietnam Pro" pitchFamily="34" charset="-122"/>
                 <a:cs typeface="Be Vietnam Pro" pitchFamily="34" charset="-120"/>
               </a:rPr>
+              <a:t> nhập</a:t>
+            </a:r>
+            <a:r>
+              <a:rPr lang="en-US" sz="2250" dirty="0" spc="2" kern="0">
+                <a:solidFill>
+                  <a:srgbClr val="14161C"/>
+                </a:solidFill>
+                <a:latin typeface="Be Vietnam Pro" pitchFamily="34" charset="0"/>
+                <a:ea typeface="Be Vietnam Pro" pitchFamily="34" charset="-122"/>
+                <a:cs typeface="Be Vietnam Pro" pitchFamily="34" charset="-120"/>
+              </a:rPr>
               <a:t> cần</a:t>
             </a:r>
             <a:r>
-              <a:rPr lang="en-US" sz="2250" dirty="0" spc="4" kern="0">
-                <a:solidFill>
-                  <a:srgbClr val="14161C"/>
-                </a:solidFill>
-                <a:latin typeface="Be Vietnam Pro" pitchFamily="34" charset="0"/>
-                <a:ea typeface="Be Vietnam Pro" pitchFamily="34" charset="-122"/>
-                <a:cs typeface="Be Vietnam Pro" pitchFamily="34" charset="-120"/>
-              </a:rPr>
-              <a:t> ID</a:t>
-            </a:r>
-            <a:r>
-              <a:rPr lang="en-US" sz="2250" dirty="0" spc="-25" kern="0">
-                <a:solidFill>
-                  <a:srgbClr val="14161C"/>
-                </a:solidFill>
-                <a:latin typeface="Be Vietnam Pro" pitchFamily="34" charset="0"/>
-                <a:ea typeface="Be Vietnam Pro" pitchFamily="34" charset="-122"/>
-                <a:cs typeface="Be Vietnam Pro" pitchFamily="34" charset="-120"/>
-              </a:rPr>
-              <a:t> token</a:t>
-            </a:r>
-            <a:r>
-              <a:rPr lang="en-US" sz="2250" dirty="0" spc="2" kern="0">
-                <a:solidFill>
-                  <a:srgbClr val="14161C"/>
-                </a:solidFill>
-                <a:latin typeface="Be Vietnam Pro" pitchFamily="34" charset="0"/>
-                <a:ea typeface="Be Vietnam Pro" pitchFamily="34" charset="-122"/>
-                <a:cs typeface="Be Vietnam Pro" pitchFamily="34" charset="-120"/>
-              </a:rPr>
-              <a:t> của</a:t>
+              <a:rPr lang="en-US" sz="2250" dirty="0" spc="-21" kern="0">
+                <a:solidFill>
+                  <a:srgbClr val="14161C"/>
+                </a:solidFill>
+                <a:latin typeface="Be Vietnam Pro" pitchFamily="34" charset="0"/>
+                <a:ea typeface="Be Vietnam Pro" pitchFamily="34" charset="-122"/>
+                <a:cs typeface="Be Vietnam Pro" pitchFamily="34" charset="-120"/>
+              </a:rPr>
+              <a:t> yêu</a:t>
+            </a:r>
+            <a:r>
+              <a:rPr lang="en-US" sz="2250" dirty="0" spc="1" kern="0">
+                <a:solidFill>
+                  <a:srgbClr val="14161C"/>
+                </a:solidFill>
+                <a:latin typeface="Be Vietnam Pro" pitchFamily="34" charset="0"/>
+                <a:ea typeface="Be Vietnam Pro" pitchFamily="34" charset="-122"/>
+                <a:cs typeface="Be Vietnam Pro" pitchFamily="34" charset="-120"/>
+              </a:rPr>
+              <a:t> cầu</a:t>
+            </a:r>
+            <a:r>
+              <a:rPr lang="en-US" sz="2250" dirty="0" spc="-8" kern="0">
+                <a:solidFill>
+                  <a:srgbClr val="14161C"/>
+                </a:solidFill>
+                <a:latin typeface="Be Vietnam Pro" pitchFamily="34" charset="0"/>
+                <a:ea typeface="Be Vietnam Pro" pitchFamily="34" charset="-122"/>
+                <a:cs typeface="Be Vietnam Pro" pitchFamily="34" charset="-120"/>
+              </a:rPr>
+              <a:t> max_age</a:t>
+            </a:r>
+            <a:r>
+              <a:rPr lang="en-US" sz="2250" dirty="0" spc="-15" kern="0">
+                <a:solidFill>
+                  <a:srgbClr val="14161C"/>
+                </a:solidFill>
+                <a:latin typeface="Be Vietnam Pro" pitchFamily="34" charset="0"/>
+                <a:ea typeface="Be Vietnam Pro" pitchFamily="34" charset="-122"/>
+                <a:cs typeface="Be Vietnam Pro" pitchFamily="34" charset="-120"/>
+              </a:rPr>
+              <a:t> và</a:t>
+            </a:r>
+            <a:r>
+              <a:rPr lang="en-US" sz="2250" dirty="0" spc="-2" kern="0">
+                <a:solidFill>
+                  <a:srgbClr val="14161C"/>
+                </a:solidFill>
+                <a:latin typeface="Be Vietnam Pro" pitchFamily="34" charset="0"/>
+                <a:ea typeface="Be Vietnam Pro" pitchFamily="34" charset="-122"/>
+                <a:cs typeface="Be Vietnam Pro" pitchFamily="34" charset="-120"/>
+              </a:rPr>
+              <a:t> kiểm</a:t>
             </a:r>
             <a:r>
               <a:rPr lang="en-US" sz="2250" dirty="0" spc="0" kern="0">
@@ -16566,18 +16742,7 @@
                 <a:ea typeface="Be Vietnam Pro" pitchFamily="34" charset="-122"/>
                 <a:cs typeface="Be Vietnam Pro" pitchFamily="34" charset="-120"/>
               </a:rPr>
-              <a:t> OpenID</a:t>
-            </a:r>
-            <a:r>
-              <a:rPr lang="en-US" sz="2250" dirty="0" spc="-1" kern="0">
-                <a:solidFill>
-                  <a:srgbClr val="14161C"/>
-                </a:solidFill>
-                <a:latin typeface="Be Vietnam Pro" pitchFamily="34" charset="0"/>
-                <a:ea typeface="Be Vietnam Pro" pitchFamily="34" charset="-122"/>
-                <a:cs typeface="Be Vietnam Pro" pitchFamily="34" charset="-120"/>
-              </a:rPr>
-              <a:t> Connect.</a:t>
+              <a:t> auth_time.</a:t>
             </a:r>
             <a:endParaRPr lang="en-US" sz="2250" dirty="0"/>
           </a:p>
@@ -16591,7 +16756,7 @@
         </p:nvSpPr>
         <p:spPr>
           <a:xfrm>
-            <a:off x="1295400" y="7715250"/>
+            <a:off x="1295400" y="7905750"/>
             <a:ext cx="1905000" cy="533400"/>
           </a:xfrm>
           <a:prstGeom prst="roundRect">
@@ -16646,11 +16811,11 @@
         <p:spPr>
           <a:xfrm>
             <a:off x="6515100" y="3810000"/>
-            <a:ext cx="5257800" cy="4762500"/>
+            <a:ext cx="5257800" cy="4953000"/>
           </a:xfrm>
           <a:prstGeom prst="roundRect">
             <a:avLst>
-              <a:gd name="adj" fmla="val 5600"/>
+              <a:gd name="adj" fmla="val 5385"/>
             </a:avLst>
           </a:prstGeom>
           <a:solidFill>
@@ -16840,6 +17005,105 @@
               <a:buNone/>
             </a:pPr>
             <a:r>
+              <a:rPr lang="en-US" sz="2250" dirty="0" spc="-62" kern="0">
+                <a:solidFill>
+                  <a:srgbClr val="14161C"/>
+                </a:solidFill>
+                <a:latin typeface="Be Vietnam Pro" pitchFamily="34" charset="0"/>
+                <a:ea typeface="Be Vietnam Pro" pitchFamily="34" charset="-122"/>
+                <a:cs typeface="Be Vietnam Pro" pitchFamily="34" charset="-120"/>
+              </a:rPr>
+              <a:t>Token</a:t>
+            </a:r>
+            <a:r>
+              <a:rPr lang="en-US" sz="2250" dirty="0" spc="-15" kern="0">
+                <a:solidFill>
+                  <a:srgbClr val="14161C"/>
+                </a:solidFill>
+                <a:latin typeface="Be Vietnam Pro" pitchFamily="34" charset="0"/>
+                <a:ea typeface="Be Vietnam Pro" pitchFamily="34" charset="-122"/>
+                <a:cs typeface="Be Vietnam Pro" pitchFamily="34" charset="-120"/>
+              </a:rPr>
+              <a:t> bearer:</a:t>
+            </a:r>
+            <a:r>
+              <a:rPr lang="en-US" sz="2250" dirty="0" spc="-2" kern="0">
+                <a:solidFill>
+                  <a:srgbClr val="14161C"/>
+                </a:solidFill>
+                <a:latin typeface="Be Vietnam Pro" pitchFamily="34" charset="0"/>
+                <a:ea typeface="Be Vietnam Pro" pitchFamily="34" charset="-122"/>
+                <a:cs typeface="Be Vietnam Pro" pitchFamily="34" charset="-120"/>
+              </a:rPr>
+              <a:t> ai</a:t>
+            </a:r>
+            <a:r>
+              <a:rPr lang="en-US" sz="2250" dirty="0" spc="5" kern="0">
+                <a:solidFill>
+                  <a:srgbClr val="14161C"/>
+                </a:solidFill>
+                <a:latin typeface="Be Vietnam Pro" pitchFamily="34" charset="0"/>
+                <a:ea typeface="Be Vietnam Pro" pitchFamily="34" charset="-122"/>
+                <a:cs typeface="Be Vietnam Pro" pitchFamily="34" charset="-120"/>
+              </a:rPr>
+              <a:t> có</a:t>
+            </a:r>
+            <a:r>
+              <a:rPr lang="en-US" sz="2250" dirty="0" spc="1" kern="0">
+                <a:solidFill>
+                  <a:srgbClr val="14161C"/>
+                </a:solidFill>
+                <a:latin typeface="Be Vietnam Pro" pitchFamily="34" charset="0"/>
+                <a:ea typeface="Be Vietnam Pro" pitchFamily="34" charset="-122"/>
+                <a:cs typeface="Be Vietnam Pro" pitchFamily="34" charset="-120"/>
+              </a:rPr>
+              <a:t> chuỗi</a:t>
+            </a:r>
+            <a:r>
+              <a:rPr lang="en-US" sz="2250" dirty="0" spc="2" kern="0">
+                <a:solidFill>
+                  <a:srgbClr val="14161C"/>
+                </a:solidFill>
+                <a:latin typeface="Be Vietnam Pro" pitchFamily="34" charset="0"/>
+                <a:ea typeface="Be Vietnam Pro" pitchFamily="34" charset="-122"/>
+                <a:cs typeface="Be Vietnam Pro" pitchFamily="34" charset="-120"/>
+              </a:rPr>
+              <a:t> cũng</a:t>
+            </a:r>
+            <a:r>
+              <a:rPr lang="en-US" sz="2250" dirty="0" spc="3" kern="0">
+                <a:solidFill>
+                  <a:srgbClr val="14161C"/>
+                </a:solidFill>
+                <a:latin typeface="Be Vietnam Pro" pitchFamily="34" charset="0"/>
+                <a:ea typeface="Be Vietnam Pro" pitchFamily="34" charset="-122"/>
+                <a:cs typeface="Be Vietnam Pro" pitchFamily="34" charset="-120"/>
+              </a:rPr>
+              <a:t> dùng</a:t>
+            </a:r>
+            <a:r>
+              <a:rPr lang="en-US" sz="2250" dirty="0" spc="6" kern="0">
+                <a:solidFill>
+                  <a:srgbClr val="14161C"/>
+                </a:solidFill>
+                <a:latin typeface="Be Vietnam Pro" pitchFamily="34" charset="0"/>
+                <a:ea typeface="Be Vietnam Pro" pitchFamily="34" charset="-122"/>
+                <a:cs typeface="Be Vietnam Pro" pitchFamily="34" charset="-120"/>
+              </a:rPr>
+              <a:t> được,</a:t>
+            </a:r>
+            <a:r>
+              <a:rPr lang="en-US" sz="2250" dirty="0" spc="5" kern="0">
+                <a:solidFill>
+                  <a:srgbClr val="14161C"/>
+                </a:solidFill>
+                <a:latin typeface="Be Vietnam Pro" pitchFamily="34" charset="0"/>
+                <a:ea typeface="Be Vietnam Pro" pitchFamily="34" charset="-122"/>
+                <a:cs typeface="Be Vietnam Pro" pitchFamily="34" charset="-120"/>
+              </a:rPr>
+              <a:t> API</a:t>
+            </a:r>
+            <a:r>
               <a:rPr lang="en-US" sz="2250" dirty="0" spc="0" kern="0">
                 <a:solidFill>
                   <a:srgbClr val="14161C"/>
@@ -16848,18 +17112,7 @@
                 <a:ea typeface="Be Vietnam Pro" pitchFamily="34" charset="-122"/>
                 <a:cs typeface="Be Vietnam Pro" pitchFamily="34" charset="-120"/>
               </a:rPr>
-              <a:t>Ai</a:t>
-            </a:r>
-            <a:r>
-              <a:rPr lang="en-US" sz="2250" dirty="0" spc="5" kern="0">
-                <a:solidFill>
-                  <a:srgbClr val="14161C"/>
-                </a:solidFill>
-                <a:latin typeface="Be Vietnam Pro" pitchFamily="34" charset="0"/>
-                <a:ea typeface="Be Vietnam Pro" pitchFamily="34" charset="-122"/>
-                <a:cs typeface="Be Vietnam Pro" pitchFamily="34" charset="-120"/>
-              </a:rPr>
-              <a:t> có</a:t>
+              <a:t> nhận</a:t>
             </a:r>
             <a:r>
               <a:rPr lang="en-US" sz="2250" dirty="0" spc="1" kern="0">
@@ -16870,73 +17123,7 @@
                 <a:ea typeface="Be Vietnam Pro" pitchFamily="34" charset="-122"/>
                 <a:cs typeface="Be Vietnam Pro" pitchFamily="34" charset="-120"/>
               </a:rPr>
-              <a:t> chuỗi</a:t>
-            </a:r>
-            <a:r>
-              <a:rPr lang="en-US" sz="2250" dirty="0" spc="-25" kern="0">
-                <a:solidFill>
-                  <a:srgbClr val="14161C"/>
-                </a:solidFill>
-                <a:latin typeface="Be Vietnam Pro" pitchFamily="34" charset="0"/>
-                <a:ea typeface="Be Vietnam Pro" pitchFamily="34" charset="-122"/>
-                <a:cs typeface="Be Vietnam Pro" pitchFamily="34" charset="-120"/>
-              </a:rPr>
-              <a:t> token</a:t>
-            </a:r>
-            <a:r>
-              <a:rPr lang="en-US" sz="2250" dirty="0" spc="3" kern="0">
-                <a:solidFill>
-                  <a:srgbClr val="14161C"/>
-                </a:solidFill>
-                <a:latin typeface="Be Vietnam Pro" pitchFamily="34" charset="0"/>
-                <a:ea typeface="Be Vietnam Pro" pitchFamily="34" charset="-122"/>
-                <a:cs typeface="Be Vietnam Pro" pitchFamily="34" charset="-120"/>
-              </a:rPr>
-              <a:t> cũng</a:t>
-            </a:r>
-            <a:r>
-              <a:rPr lang="en-US" sz="2250" dirty="0" spc="2" kern="0">
-                <a:solidFill>
-                  <a:srgbClr val="14161C"/>
-                </a:solidFill>
-                <a:latin typeface="Be Vietnam Pro" pitchFamily="34" charset="0"/>
-                <a:ea typeface="Be Vietnam Pro" pitchFamily="34" charset="-122"/>
-                <a:cs typeface="Be Vietnam Pro" pitchFamily="34" charset="-120"/>
-              </a:rPr>
-              <a:t> dùng</a:t>
-            </a:r>
-            <a:r>
-              <a:rPr lang="en-US" sz="2250" dirty="0" spc="9" kern="0">
-                <a:solidFill>
-                  <a:srgbClr val="14161C"/>
-                </a:solidFill>
-                <a:latin typeface="Be Vietnam Pro" pitchFamily="34" charset="0"/>
-                <a:ea typeface="Be Vietnam Pro" pitchFamily="34" charset="-122"/>
-                <a:cs typeface="Be Vietnam Pro" pitchFamily="34" charset="-120"/>
-              </a:rPr>
-              <a:t> được:</a:t>
-            </a:r>
-            <a:r>
-              <a:rPr lang="en-US" sz="2250" dirty="0" spc="3" kern="0">
-                <a:solidFill>
-                  <a:srgbClr val="14161C"/>
-                </a:solidFill>
-                <a:latin typeface="Be Vietnam Pro" pitchFamily="34" charset="0"/>
-                <a:ea typeface="Be Vietnam Pro" pitchFamily="34" charset="-122"/>
-                <a:cs typeface="Be Vietnam Pro" pitchFamily="34" charset="-120"/>
-              </a:rPr>
-              <a:t> API</a:t>
-            </a:r>
-            <a:r>
-              <a:rPr lang="en-US" sz="2250" dirty="0" spc="1" kern="0">
-                <a:solidFill>
-                  <a:srgbClr val="14161C"/>
-                </a:solidFill>
-                <a:latin typeface="Be Vietnam Pro" pitchFamily="34" charset="0"/>
-                <a:ea typeface="Be Vietnam Pro" pitchFamily="34" charset="-122"/>
-                <a:cs typeface="Be Vietnam Pro" pitchFamily="34" charset="-120"/>
-              </a:rPr>
-              <a:t> nhận 200.</a:t>
+              <a:t> 200.</a:t>
             </a:r>
             <a:endParaRPr lang="en-US" sz="2250" dirty="0"/>
           </a:p>
@@ -16950,7 +17137,7 @@
         </p:nvSpPr>
         <p:spPr>
           <a:xfrm>
-            <a:off x="6896100" y="7715250"/>
+            <a:off x="6896100" y="7905750"/>
             <a:ext cx="1905000" cy="533400"/>
           </a:xfrm>
           <a:prstGeom prst="roundRect">
@@ -16994,11 +17181,11 @@
         <p:spPr>
           <a:xfrm>
             <a:off x="12115800" y="3810000"/>
-            <a:ext cx="5257800" cy="4762500"/>
+            <a:ext cx="5257800" cy="4953000"/>
           </a:xfrm>
           <a:prstGeom prst="roundRect">
             <a:avLst>
-              <a:gd name="adj" fmla="val 5600"/>
+              <a:gd name="adj" fmla="val 5385"/>
             </a:avLst>
           </a:prstGeom>
           <a:solidFill>
@@ -17254,7 +17441,7 @@
         </p:nvSpPr>
         <p:spPr>
           <a:xfrm>
-            <a:off x="12496800" y="7715250"/>
+            <a:off x="12496800" y="7905750"/>
             <a:ext cx="1905000" cy="533400"/>
           </a:xfrm>
           <a:prstGeom prst="roundRect">

</xml_diff>

<commit_message>
System Design vi: sd-14-035 deck says the validator checks typ only when the header has it
Co-Authored-By: Claude Sonnet 5.5 <noreply@anthropic.com>
Claude-Session: https://claude.ai/code/session_01WnjciXNJBLEd8jy3HrG49S
</commit_message>
<xml_diff>
--- a/system-design-101/vi/lessons/sd-14-035/slides/sd-14-035.pptx
+++ b/system-design-101/vi/lessons/sd-14-035/slides/sd-14-035.pptx
@@ -3760,7 +3760,7 @@
               <a:t> kiểm</a:t>
             </a:r>
             <a:r>
-              <a:rPr lang="en-US" sz="2100" dirty="0" spc="3" kern="0">
+              <a:rPr lang="en-US" sz="2100" dirty="0" spc="2" kern="0">
                 <a:solidFill>
                   <a:srgbClr val="D8D3C4"/>
                 </a:solidFill>
@@ -3768,7 +3768,7 @@
                 <a:ea typeface="Be Vietnam Pro" pitchFamily="34" charset="-122"/>
                 <a:cs typeface="Be Vietnam Pro" pitchFamily="34" charset="-120"/>
               </a:rPr>
-              <a:t> iss</a:t>
+              <a:t> iss,</a:t>
             </a:r>
             <a:r>
               <a:rPr lang="en-US" sz="2100" dirty="0" spc="-18" kern="0">
@@ -3782,7 +3782,7 @@
               <a:t> và</a:t>
             </a:r>
             <a:r>
-              <a:rPr lang="en-US" sz="2100" dirty="0" spc="-7" kern="0">
+              <a:rPr lang="en-US" sz="2100" dirty="0" spc="-8" kern="0">
                 <a:solidFill>
                   <a:srgbClr val="D8D3C4"/>
                 </a:solidFill>
@@ -3790,7 +3790,40 @@
                 <a:ea typeface="Be Vietnam Pro" pitchFamily="34" charset="-122"/>
                 <a:cs typeface="Be Vietnam Pro" pitchFamily="34" charset="-120"/>
               </a:rPr>
-              <a:t> typ.</a:t>
+              <a:t> typ</a:t>
+            </a:r>
+            <a:r>
+              <a:rPr lang="en-US" sz="2100" dirty="0" spc="1" kern="0">
+                <a:solidFill>
+                  <a:srgbClr val="D8D3C4"/>
+                </a:solidFill>
+                <a:latin typeface="Be Vietnam Pro" pitchFamily="34" charset="0"/>
+                <a:ea typeface="Be Vietnam Pro" pitchFamily="34" charset="-122"/>
+                <a:cs typeface="Be Vietnam Pro" pitchFamily="34" charset="-120"/>
+              </a:rPr>
+              <a:t> nếu</a:t>
+            </a:r>
+            <a:r>
+              <a:rPr lang="en-US" sz="2100" dirty="0" spc="-5" kern="0">
+                <a:solidFill>
+                  <a:srgbClr val="D8D3C4"/>
+                </a:solidFill>
+                <a:latin typeface="Be Vietnam Pro" pitchFamily="34" charset="0"/>
+                <a:ea typeface="Be Vietnam Pro" pitchFamily="34" charset="-122"/>
+                <a:cs typeface="Be Vietnam Pro" pitchFamily="34" charset="-120"/>
+              </a:rPr>
+              <a:t> header</a:t>
+            </a:r>
+            <a:r>
+              <a:rPr lang="en-US" sz="2100" dirty="0" spc="-3" kern="0">
+                <a:solidFill>
+                  <a:srgbClr val="D8D3C4"/>
+                </a:solidFill>
+                <a:latin typeface="Be Vietnam Pro" pitchFamily="34" charset="0"/>
+                <a:ea typeface="Be Vietnam Pro" pitchFamily="34" charset="-122"/>
+                <a:cs typeface="Be Vietnam Pro" pitchFamily="34" charset="-120"/>
+              </a:rPr>
+              <a:t> có.</a:t>
             </a:r>
             <a:endParaRPr lang="en-US" sz="2100" dirty="0"/>
           </a:p>
@@ -12951,8 +12984,8 @@
         </p:nvSpPr>
         <p:spPr>
           <a:xfrm>
-            <a:off x="11582400" y="990600"/>
-            <a:ext cx="5791200" cy="1447800"/>
+            <a:off x="11049000" y="990600"/>
+            <a:ext cx="6324600" cy="1447800"/>
           </a:xfrm>
           <a:prstGeom prst="roundRect">
             <a:avLst>
@@ -12978,8 +13011,8 @@
         </p:nvSpPr>
         <p:spPr>
           <a:xfrm>
-            <a:off x="11887200" y="1181100"/>
-            <a:ext cx="5181600" cy="285750"/>
+            <a:off x="11353800" y="1181100"/>
+            <a:ext cx="5715000" cy="285750"/>
           </a:xfrm>
           <a:prstGeom prst="rect">
             <a:avLst/>
@@ -13061,8 +13094,8 @@
         </p:nvSpPr>
         <p:spPr>
           <a:xfrm>
-            <a:off x="11887200" y="1581150"/>
-            <a:ext cx="5181600" cy="361950"/>
+            <a:off x="11353800" y="1581150"/>
+            <a:ext cx="5715000" cy="361950"/>
           </a:xfrm>
           <a:prstGeom prst="rect">
             <a:avLst/>
@@ -13111,7 +13144,7 @@
               <a:t> kiểm</a:t>
             </a:r>
             <a:r>
-              <a:rPr lang="en-US" sz="2100" dirty="0" spc="-6" kern="0">
+              <a:rPr lang="en-US" sz="2100" dirty="0" spc="-5" kern="0">
                 <a:solidFill>
                   <a:srgbClr val="14161C"/>
                 </a:solidFill>
@@ -13119,7 +13152,7 @@
                 <a:ea typeface="Be Vietnam Pro SemiBold" pitchFamily="34" charset="-122"/>
                 <a:cs typeface="Be Vietnam Pro SemiBold" pitchFamily="34" charset="-120"/>
               </a:rPr>
-              <a:t> iss</a:t>
+              <a:t> iss,</a:t>
             </a:r>
             <a:r>
               <a:rPr lang="en-US" sz="2100" dirty="0" spc="-20" kern="0">
@@ -13141,7 +13174,18 @@
                 <a:ea typeface="Be Vietnam Pro SemiBold" pitchFamily="34" charset="-122"/>
                 <a:cs typeface="Be Vietnam Pro SemiBold" pitchFamily="34" charset="-120"/>
               </a:rPr>
-              <a:t> typ.</a:t>
+              <a:t> typ nếu</a:t>
+            </a:r>
+            <a:r>
+              <a:rPr lang="en-US" sz="2100" dirty="0" spc="-5" kern="0">
+                <a:solidFill>
+                  <a:srgbClr val="14161C"/>
+                </a:solidFill>
+                <a:latin typeface="Be Vietnam Pro SemiBold" pitchFamily="34" charset="0"/>
+                <a:ea typeface="Be Vietnam Pro SemiBold" pitchFamily="34" charset="-122"/>
+                <a:cs typeface="Be Vietnam Pro SemiBold" pitchFamily="34" charset="-120"/>
+              </a:rPr>
+              <a:t> header có.</a:t>
             </a:r>
             <a:endParaRPr lang="en-US" sz="2100" dirty="0"/>
           </a:p>
@@ -13155,8 +13199,8 @@
         </p:nvSpPr>
         <p:spPr>
           <a:xfrm>
-            <a:off x="11887200" y="1981200"/>
-            <a:ext cx="5181600" cy="361950"/>
+            <a:off x="11353800" y="1981200"/>
+            <a:ext cx="5715000" cy="361950"/>
           </a:xfrm>
           <a:prstGeom prst="rect">
             <a:avLst/>
@@ -24336,11 +24380,11 @@
         <p:spPr>
           <a:xfrm>
             <a:off x="914400" y="4476750"/>
-            <a:ext cx="8991600" cy="4286250"/>
+            <a:ext cx="8991600" cy="4572000"/>
           </a:xfrm>
           <a:prstGeom prst="roundRect">
             <a:avLst>
-              <a:gd name="adj" fmla="val 6222"/>
+              <a:gd name="adj" fmla="val 5833"/>
             </a:avLst>
           </a:prstGeom>
           <a:solidFill>
@@ -25010,7 +25054,7 @@
         <p:spPr>
           <a:xfrm>
             <a:off x="10439400" y="1428750"/>
-            <a:ext cx="6934200" cy="7334250"/>
+            <a:ext cx="6934200" cy="7620000"/>
           </a:xfrm>
           <a:prstGeom prst="roundRect">
             <a:avLst>
@@ -25204,7 +25248,7 @@
         </p:nvSpPr>
         <p:spPr>
           <a:xfrm>
-            <a:off x="10915650" y="4400550"/>
+            <a:off x="10915650" y="4248150"/>
             <a:ext cx="5981700" cy="457200"/>
           </a:xfrm>
           <a:prstGeom prst="rect">
@@ -25320,7 +25364,7 @@
         </p:nvSpPr>
         <p:spPr>
           <a:xfrm>
-            <a:off x="10915650" y="5010150"/>
+            <a:off x="10915650" y="4838700"/>
             <a:ext cx="5981700" cy="2019300"/>
           </a:xfrm>
           <a:prstGeom prst="rect">
@@ -25579,7 +25623,7 @@
         </p:nvSpPr>
         <p:spPr>
           <a:xfrm>
-            <a:off x="10915650" y="7105650"/>
+            <a:off x="10915650" y="6953250"/>
             <a:ext cx="5981700" cy="0"/>
           </a:xfrm>
           <a:prstGeom prst="line">
@@ -25606,7 +25650,7 @@
         </p:nvSpPr>
         <p:spPr>
           <a:xfrm>
-            <a:off x="10915650" y="7239000"/>
+            <a:off x="10915650" y="7086600"/>
             <a:ext cx="5981700" cy="628650"/>
           </a:xfrm>
           <a:prstGeom prst="rect">
@@ -26106,8 +26150,8 @@
         </p:nvSpPr>
         <p:spPr>
           <a:xfrm>
-            <a:off x="10915650" y="7981950"/>
-            <a:ext cx="5981700" cy="666750"/>
+            <a:off x="10915650" y="7848600"/>
+            <a:ext cx="5981700" cy="990600"/>
           </a:xfrm>
           <a:prstGeom prst="rect">
             <a:avLst/>
@@ -26183,6 +26227,9 @@
               </a:rPr>
               <a:t> token:</a:t>
             </a:r>
+            <a:endParaRPr lang="en-US" sz="1800" dirty="0"/>
+          </a:p>
+          <a:p>
             <a:pPr algn="l" indent="0" marL="0">
               <a:lnSpc>
                 <a:spcPts val="2340"/>
@@ -26193,7 +26240,7 @@
               <a:buNone/>
             </a:pPr>
             <a:r>
-              <a:rPr lang="en-US" sz="1800" dirty="0" spc="7" kern="0">
+              <a:rPr lang="en-US" sz="1800" dirty="0" spc="9" kern="0">
                 <a:solidFill>
                   <a:srgbClr val="FFFFFF"/>
                 </a:solidFill>
@@ -26201,7 +26248,7 @@
                 <a:ea typeface="Be Vietnam Pro" pitchFamily="34" charset="-122"/>
                 <a:cs typeface="Be Vietnam Pro" pitchFamily="34" charset="-120"/>
               </a:rPr>
-              <a:t> JWT</a:t>
+              <a:t>JWT</a:t>
             </a:r>
             <a:r>
               <a:rPr lang="en-US" sz="1800" dirty="0" spc="-1" kern="0">
@@ -26215,6 +26262,50 @@
               <a:t> còn kiểm</a:t>
             </a:r>
             <a:r>
+              <a:rPr lang="en-US" sz="1800" dirty="0" spc="0" kern="0">
+                <a:solidFill>
+                  <a:srgbClr val="FFFFFF"/>
+                </a:solidFill>
+                <a:latin typeface="Be Vietnam Pro" pitchFamily="34" charset="0"/>
+                <a:ea typeface="Be Vietnam Pro" pitchFamily="34" charset="-122"/>
+                <a:cs typeface="Be Vietnam Pro" pitchFamily="34" charset="-120"/>
+              </a:rPr>
+              <a:t> iss,</a:t>
+            </a:r>
+            <a:r>
+              <a:rPr lang="en-US" sz="1800" dirty="0" spc="-12" kern="0">
+                <a:solidFill>
+                  <a:srgbClr val="FFFFFF"/>
+                </a:solidFill>
+                <a:latin typeface="Be Vietnam Pro" pitchFamily="34" charset="0"/>
+                <a:ea typeface="Be Vietnam Pro" pitchFamily="34" charset="-122"/>
+                <a:cs typeface="Be Vietnam Pro" pitchFamily="34" charset="-120"/>
+              </a:rPr>
+              <a:t> và</a:t>
+            </a:r>
+            <a:r>
+              <a:rPr lang="en-US" sz="1800" dirty="0" spc="-6" kern="0">
+                <a:solidFill>
+                  <a:srgbClr val="FFFFFF"/>
+                </a:solidFill>
+                <a:latin typeface="Be Vietnam Pro" pitchFamily="34" charset="0"/>
+                <a:ea typeface="Be Vietnam Pro" pitchFamily="34" charset="-122"/>
+                <a:cs typeface="Be Vietnam Pro" pitchFamily="34" charset="-120"/>
+              </a:rPr>
+              <a:t> typ</a:t>
+            </a:r>
+            <a:r>
+              <a:rPr lang="en-US" sz="1800" dirty="0" spc="-3" kern="0">
+                <a:solidFill>
+                  <a:srgbClr val="FFFFFF"/>
+                </a:solidFill>
+                <a:latin typeface="Be Vietnam Pro" pitchFamily="34" charset="0"/>
+                <a:ea typeface="Be Vietnam Pro" pitchFamily="34" charset="-122"/>
+                <a:cs typeface="Be Vietnam Pro" pitchFamily="34" charset="-120"/>
+              </a:rPr>
+              <a:t> nếu</a:t>
+            </a:r>
+            <a:r>
               <a:rPr lang="en-US" sz="1800" dirty="0" spc="1" kern="0">
                 <a:solidFill>
                   <a:srgbClr val="FFFFFF"/>
@@ -26223,29 +26314,7 @@
                 <a:ea typeface="Be Vietnam Pro" pitchFamily="34" charset="-122"/>
                 <a:cs typeface="Be Vietnam Pro" pitchFamily="34" charset="-120"/>
               </a:rPr>
-              <a:t> iss</a:t>
-            </a:r>
-            <a:r>
-              <a:rPr lang="en-US" sz="1800" dirty="0" spc="-12" kern="0">
-                <a:solidFill>
-                  <a:srgbClr val="FFFFFF"/>
-                </a:solidFill>
-                <a:latin typeface="Be Vietnam Pro" pitchFamily="34" charset="0"/>
-                <a:ea typeface="Be Vietnam Pro" pitchFamily="34" charset="-122"/>
-                <a:cs typeface="Be Vietnam Pro" pitchFamily="34" charset="-120"/>
-              </a:rPr>
-              <a:t> và</a:t>
-            </a:r>
-            <a:r>
-              <a:rPr lang="en-US" sz="1800" dirty="0" spc="-4" kern="0">
-                <a:solidFill>
-                  <a:srgbClr val="FFFFFF"/>
-                </a:solidFill>
-                <a:latin typeface="Be Vietnam Pro" pitchFamily="34" charset="0"/>
-                <a:ea typeface="Be Vietnam Pro" pitchFamily="34" charset="-122"/>
-                <a:cs typeface="Be Vietnam Pro" pitchFamily="34" charset="-120"/>
-              </a:rPr>
-              <a:t> typ.</a:t>
+              <a:t> header có.</a:t>
             </a:r>
             <a:endParaRPr lang="en-US" sz="1800" dirty="0"/>
           </a:p>

</xml_diff>